<commit_message>
adopt the merged pipeline: build instances via qaoa_instance, add per-link tests
Route every instance build through qaoa_instance.build so the qubit budget,
the Yen diversity knob and the priority mapping come from one place, and
record diversity in the study output.

Re-verify against the merged code. The diversity knob does not rescue
east10_dense: at every setting from 0.0 to 1.0 no assignment clears capacity,
confirming that instance is oversubscribed rather than short of route
diversity. On east10_tuned the better shortlist raises clean assignments from
112 to 288 of 16384, and the per-link profile still takes the peak from 105%
to 90% with zero violations, now at Phi 4068 -> 1452.

Add the per-link profile to the weight study so the reported configuration
appears in its own comparison, and cover the profile with five tests.
</commit_message>
<xml_diff>
--- a/presentation/dist/qubit_pitch.pptx
+++ b/presentation/dist/qubit_pitch.pptx
@@ -6418,7 +6418,7 @@
                 </a:solidFill>
                 <a:latin typeface="Arial"/>
               </a:rPr>
-              <a:t>5.84 → 2.05</a:t>
+              <a:t>5.84 → 2.03</a:t>
             </a:r>
           </a:p>
         </p:txBody>
@@ -7296,7 +7296,7 @@
                 </a:solidFill>
                 <a:latin typeface="Arial"/>
               </a:rPr>
-              <a:t>28 qubits synthesized on Classiq to depth 96 with 162 two-qubit gates, executed on the simulator. CVaR falls from 47.1 to 11.8, so the optimizer is learning.</a:t>
+              <a:t>28 qubits synthesized on Classiq to depth 75 with 150 two-qubit gates, executed on the simulator. The CVaR of sampled H falls by 18.5 (-20.3 to -38.7; the per-link fit drops constant terms, so H is not positive), meaning the optimizer is learning.</a:t>
             </a:r>
           </a:p>
         </p:txBody>
@@ -8213,7 +8213,7 @@
                 </a:solidFill>
                 <a:latin typeface="Arial"/>
               </a:rPr>
-              <a:t>44 tests, one of them exhaustive</a:t>
+              <a:t>49 tests, one of them exhaustive</a:t>
             </a:r>
           </a:p>
         </p:txBody>
@@ -8798,7 +8798,7 @@
                 </a:solidFill>
                 <a:latin typeface="Arial"/>
               </a:rPr>
-              <a:t>Φ* 5.8 → 2.1</a:t>
+              <a:t>Φ* 5.8 → 2.0</a:t>
             </a:r>
           </a:p>
         </p:txBody>
@@ -9047,7 +9047,7 @@
                 </a:solidFill>
                 <a:latin typeface="Arial"/>
               </a:rPr>
-              <a:t>44 tests</a:t>
+              <a:t>49 tests</a:t>
             </a:r>
           </a:p>
         </p:txBody>

</xml_diff>